<commit_message>
docs: new-design screenshots in the deck and README
- docs/shots.py re-shoots the redesigned app (video frozen on one frame, tool shots scrolled to the
  panel, model switch labels from the API) and adds 6_mobile_ar.png
- Deck: "The app" slide shows the landing page plus mobile EN and AR; titles 36 -> 32 pt so none wrap
- README gallery: landing + mobile, result EN + AR, dashboard + Arabic mobile result

Co-Authored-By: Claude Opus 5.5 <noreply@anthropic.com>
</commit_message>
<xml_diff>
--- a/docs/Real-or-Clone.pptx
+++ b/docs/Real-or-Clone.pptx
@@ -3241,7 +3241,7 @@
         <p:spPr>
           <a:xfrm>
             <a:off x="548640" y="960120"/>
-            <a:ext cx="10972800" cy="1005840"/>
+            <a:ext cx="11155680" cy="1005840"/>
           </a:xfrm>
           <a:prstGeom prst="rect">
             <a:avLst/>
@@ -3260,7 +3260,7 @@
               </a:spcAft>
             </a:pPr>
             <a:r>
-              <a:rPr sz="3600" b="1">
+              <a:rPr sz="3200" b="1">
                 <a:solidFill>
                   <a:srgbClr val="F3F1EA"/>
                 </a:solidFill>
@@ -3686,7 +3686,7 @@
         <p:spPr>
           <a:xfrm>
             <a:off x="548640" y="960120"/>
-            <a:ext cx="10972800" cy="1005840"/>
+            <a:ext cx="11155680" cy="1005840"/>
           </a:xfrm>
           <a:prstGeom prst="rect">
             <a:avLst/>
@@ -3705,7 +3705,7 @@
               </a:spcAft>
             </a:pPr>
             <a:r>
-              <a:rPr sz="3600" b="1">
+              <a:rPr sz="3200" b="1">
                 <a:solidFill>
                   <a:srgbClr val="F3F1EA"/>
                 </a:solidFill>
@@ -4094,7 +4094,7 @@
         <p:spPr>
           <a:xfrm>
             <a:off x="548640" y="960120"/>
-            <a:ext cx="10972800" cy="1005840"/>
+            <a:ext cx="11155680" cy="1005840"/>
           </a:xfrm>
           <a:prstGeom prst="rect">
             <a:avLst/>
@@ -4113,7 +4113,7 @@
               </a:spcAft>
             </a:pPr>
             <a:r>
-              <a:rPr sz="3600" b="1">
+              <a:rPr sz="3200" b="1">
                 <a:solidFill>
                   <a:srgbClr val="F3F1EA"/>
                 </a:solidFill>
@@ -4498,7 +4498,7 @@
         <p:spPr>
           <a:xfrm>
             <a:off x="548640" y="960120"/>
-            <a:ext cx="10972800" cy="1005840"/>
+            <a:ext cx="11155680" cy="1005840"/>
           </a:xfrm>
           <a:prstGeom prst="rect">
             <a:avLst/>
@@ -4517,7 +4517,7 @@
               </a:spcAft>
             </a:pPr>
             <a:r>
-              <a:rPr sz="3600" b="1">
+              <a:rPr sz="3200" b="1">
                 <a:solidFill>
                   <a:srgbClr val="F3F1EA"/>
                 </a:solidFill>
@@ -5207,7 +5207,7 @@
         <p:spPr>
           <a:xfrm>
             <a:off x="548640" y="960120"/>
-            <a:ext cx="10972800" cy="1005840"/>
+            <a:ext cx="11155680" cy="1005840"/>
           </a:xfrm>
           <a:prstGeom prst="rect">
             <a:avLst/>
@@ -5226,7 +5226,7 @@
               </a:spcAft>
             </a:pPr>
             <a:r>
-              <a:rPr sz="3600" b="1">
+              <a:rPr sz="3200" b="1">
                 <a:solidFill>
                   <a:srgbClr val="F3F1EA"/>
                 </a:solidFill>
@@ -5311,7 +5311,7 @@
         <p:spPr>
           <a:xfrm>
             <a:off x="548640" y="1920240"/>
-            <a:ext cx="5535605" cy="4572000"/>
+            <a:ext cx="5486400" cy="4572000"/>
           </a:xfrm>
           <a:prstGeom prst="rect">
             <a:avLst/>
@@ -5664,7 +5664,7 @@
         <p:spPr>
           <a:xfrm>
             <a:off x="548640" y="960120"/>
-            <a:ext cx="10972800" cy="1005840"/>
+            <a:ext cx="11155680" cy="1005840"/>
           </a:xfrm>
           <a:prstGeom prst="rect">
             <a:avLst/>
@@ -5683,7 +5683,7 @@
               </a:spcAft>
             </a:pPr>
             <a:r>
-              <a:rPr sz="3600" b="1">
+              <a:rPr sz="3200" b="1">
                 <a:solidFill>
                   <a:srgbClr val="F3F1EA"/>
                 </a:solidFill>
@@ -6738,7 +6738,7 @@
         <p:spPr>
           <a:xfrm>
             <a:off x="548640" y="960120"/>
-            <a:ext cx="10972800" cy="1005840"/>
+            <a:ext cx="11155680" cy="1005840"/>
           </a:xfrm>
           <a:prstGeom prst="rect">
             <a:avLst/>
@@ -6757,7 +6757,7 @@
               </a:spcAft>
             </a:pPr>
             <a:r>
-              <a:rPr sz="3600" b="1">
+              <a:rPr sz="3200" b="1">
                 <a:solidFill>
                   <a:srgbClr val="F3F1EA"/>
                 </a:solidFill>
@@ -7268,7 +7268,7 @@
         <p:spPr>
           <a:xfrm>
             <a:off x="548640" y="960120"/>
-            <a:ext cx="10972800" cy="1005840"/>
+            <a:ext cx="11155680" cy="1005840"/>
           </a:xfrm>
           <a:prstGeom prst="rect">
             <a:avLst/>
@@ -7287,7 +7287,7 @@
               </a:spcAft>
             </a:pPr>
             <a:r>
-              <a:rPr sz="3600" b="1">
+              <a:rPr sz="3200" b="1">
                 <a:solidFill>
                   <a:srgbClr val="F3F1EA"/>
                 </a:solidFill>
@@ -7650,7 +7650,7 @@
         <p:spPr>
           <a:xfrm>
             <a:off x="548640" y="960120"/>
-            <a:ext cx="10972800" cy="1005840"/>
+            <a:ext cx="11155680" cy="1005840"/>
           </a:xfrm>
           <a:prstGeom prst="rect">
             <a:avLst/>
@@ -7669,7 +7669,7 @@
               </a:spcAft>
             </a:pPr>
             <a:r>
-              <a:rPr sz="3600" b="1">
+              <a:rPr sz="3200" b="1">
                 <a:solidFill>
                   <a:srgbClr val="F3F1EA"/>
                 </a:solidFill>
@@ -7973,7 +7973,7 @@
         <p:spPr>
           <a:xfrm>
             <a:off x="548640" y="960120"/>
-            <a:ext cx="10972800" cy="1005840"/>
+            <a:ext cx="11155680" cy="1005840"/>
           </a:xfrm>
           <a:prstGeom prst="rect">
             <a:avLst/>
@@ -7992,7 +7992,7 @@
               </a:spcAft>
             </a:pPr>
             <a:r>
-              <a:rPr sz="3600" b="1">
+              <a:rPr sz="3200" b="1">
                 <a:solidFill>
                   <a:srgbClr val="F3F1EA"/>
                 </a:solidFill>
@@ -8062,7 +8062,7 @@
       </p:sp>
       <p:pic>
         <p:nvPicPr>
-          <p:cNvPr id="7" name="!!shot" descr="4_dashboard.png"/>
+          <p:cNvPr id="7" name="!!shot" descr="1_home.png"/>
           <p:cNvPicPr>
             <a:picLocks noChangeAspect="1"/>
           </p:cNvPicPr>
@@ -8077,7 +8077,7 @@
         <p:spPr>
           <a:xfrm>
             <a:off x="548640" y="1920240"/>
-            <a:ext cx="5206030" cy="4480560"/>
+            <a:ext cx="6729984" cy="4206240"/>
           </a:xfrm>
           <a:prstGeom prst="rect">
             <a:avLst/>
@@ -8086,7 +8086,7 @@
       </p:pic>
       <p:pic>
         <p:nvPicPr>
-          <p:cNvPr id="8" name="Picture 7" descr="3_result_ar.png"/>
+          <p:cNvPr id="8" name="Picture 7" descr="5_mobile.png"/>
           <p:cNvPicPr>
             <a:picLocks noChangeAspect="1"/>
           </p:cNvPicPr>
@@ -8100,8 +8100,8 @@
         </p:blipFill>
         <p:spPr>
           <a:xfrm>
-            <a:off x="6035040" y="1920240"/>
-            <a:ext cx="5394654" cy="4480560"/>
+            <a:off x="7589520" y="1920240"/>
+            <a:ext cx="1943642" cy="4206240"/>
           </a:xfrm>
           <a:prstGeom prst="rect">
             <a:avLst/>
@@ -8110,7 +8110,7 @@
       </p:pic>
       <p:pic>
         <p:nvPicPr>
-          <p:cNvPr id="9" name="Picture 8" descr="5_mobile.png"/>
+          <p:cNvPr id="9" name="Picture 8" descr="6_mobile_ar.png"/>
           <p:cNvPicPr>
             <a:picLocks noChangeAspect="1"/>
           </p:cNvPicPr>
@@ -8124,8 +8124,8 @@
         </p:blipFill>
         <p:spPr>
           <a:xfrm>
-            <a:off x="10058400" y="1920240"/>
-            <a:ext cx="2070401" cy="4480560"/>
+            <a:off x="9784080" y="1920240"/>
+            <a:ext cx="1943642" cy="4206240"/>
           </a:xfrm>
           <a:prstGeom prst="rect">
             <a:avLst/>
@@ -8305,7 +8305,7 @@
         <p:spPr>
           <a:xfrm>
             <a:off x="548640" y="960120"/>
-            <a:ext cx="10972800" cy="1005840"/>
+            <a:ext cx="11155680" cy="1005840"/>
           </a:xfrm>
           <a:prstGeom prst="rect">
             <a:avLst/>
@@ -8324,7 +8324,7 @@
               </a:spcAft>
             </a:pPr>
             <a:r>
-              <a:rPr sz="3600" b="1">
+              <a:rPr sz="3200" b="1">
                 <a:solidFill>
                   <a:srgbClr val="F3F1EA"/>
                 </a:solidFill>

</xml_diff>

<commit_message>
feat: run it on your own computer; publish the model and the dataset recipe
- The judging host (NVIDIA Brev) is shut down; the README now has a step-by-step
  "Run it on your computer" guide (Windows/macOS/Linux, no GPU, optional Groq/Clerk keys)
- The app downloads the fine-tuned weights from Hugging Face when there is no local
  checkpoint: IlyasDaoud/real-or-clone-xlsr (model card: results, limits, CC-BY-NC)
- DATA.md (also IlyasDaoud/real-or-clone-data): composition, sources and licences, leak-free
  splits, voice-note recipe, layout and the seeded rebuild steps (the audio itself was lost
  with the GPU box)
- App stat "<1 s" (GPU-only) replaced by "Local: your audio stays on your computer";
  deck, screenshots and the 90 s video end card updated; SUBMISSION.md notes the retired link

Co-Authored-By: Claude Opus 5.5 <noreply@anthropic.com>
</commit_message>
<xml_diff>
--- a/docs/Real-or-Clone.pptx
+++ b/docs/Real-or-Clone.pptx
@@ -3474,7 +3474,7 @@
                 </a:solidFill>
                 <a:latin typeface="Segoe UI"/>
               </a:rPr>
-              <a:t>Live: </a:t>
+              <a:t>Run it: </a:t>
             </a:r>
             <a:r>
               <a:rPr sz="1600" b="0">
@@ -3483,7 +3483,7 @@
                 </a:solidFill>
                 <a:latin typeface="Segoe UI"/>
               </a:rPr>
-              <a:t>real-or-clone-9m7lxdq0i.gobrev.dev</a:t>
+              <a:t>free &amp; open source, on your own computer</a:t>
             </a:r>
           </a:p>
           <a:p>
@@ -3916,7 +3916,7 @@
                 </a:solidFill>
                 <a:latin typeface="Segoe UI"/>
               </a:rPr>
-              <a:t>real-or-clone-9m7lxdq0i.gobrev.dev — sign in with Google or email</a:t>
+              <a:t>download the repo and run it on any laptop — steps in the README · model on Hugging Face: IlyasDaoud/real-or-clone-xlsr</a:t>
             </a:r>
           </a:p>
         </p:txBody>
@@ -4320,7 +4320,7 @@
                 </a:solidFill>
                 <a:latin typeface="Segoe UI"/>
               </a:rPr>
-              <a:t>real-or-clone-9m7lxdq0i.gobrev.dev</a:t>
+              <a:t>github.com/ilyasdaoudrma/real-or-clone</a:t>
             </a:r>
           </a:p>
         </p:txBody>
@@ -5232,7 +5232,7 @@
                 </a:solidFill>
                 <a:latin typeface="Segoe UI"/>
               </a:rPr>
-              <a:t>Upload or record a voice note. Get the truth in &lt; 1 s.</a:t>
+              <a:t>Upload or record a voice note. Get the truth in seconds.</a:t>
             </a:r>
           </a:p>
         </p:txBody>

</xml_diff>